<commit_message>
Update prior-art deck and notes; add talk transcripts
</commit_message>
<xml_diff>
--- a/Internal-Knowledge-Bases-Prior-Art-v2.pptx
+++ b/Internal-Knowledge-Bases-Prior-Art-v2.pptx
@@ -10805,7 +10805,7 @@
                 <a:ea typeface="Calibri" pitchFamily="34" charset="-122"/>
                 <a:cs typeface="Calibri" pitchFamily="34" charset="-120"/>
               </a:rPr>
-              <a:t>FIRST-PARTY PR / SEARCH-SURFACED</a:t>
+              <a:t>FIRST-PARTY PR</a:t>
             </a:r>
             <a:endParaRPr lang="en-US" sz="850" dirty="0"/>
           </a:p>
@@ -10847,7 +10847,18 @@
                 <a:ea typeface="Calibri" pitchFamily="34" charset="-122"/>
                 <a:cs typeface="Calibri" pitchFamily="34" charset="-120"/>
               </a:rPr>
-              <a:t>AskResearchGPT. </a:t>
+              <a:t>Assistant and AskResearchGPT. </a:t>
+            </a:r>
+            <a:r>
+              <a:rPr lang="en-US" sz="1550" b="0" dirty="0">
+                <a:solidFill>
+                  <a:srgbClr val="232833"/>
+                </a:solidFill>
+                <a:latin typeface="Calibri" pitchFamily="34" charset="0"/>
+                <a:ea typeface="Calibri" pitchFamily="34" charset="-122"/>
+                <a:cs typeface="Calibri" pitchFamily="34" charset="-120"/>
+              </a:rPr>
+              <a:t>One vetted corpus, and a person who edits before the client sees anything.</a:t>
             </a:r>
             <a:pPr indent="0" marL="0">
               <a:lnSpc>
@@ -10855,17 +10866,6 @@
               </a:lnSpc>
               <a:buNone/>
             </a:pPr>
-            <a:r>
-              <a:rPr lang="en-US" sz="1550" dirty="0">
-                <a:solidFill>
-                  <a:srgbClr val="232833"/>
-                </a:solidFill>
-                <a:latin typeface="Calibri" pitchFamily="34" charset="0"/>
-                <a:ea typeface="Calibri" pitchFamily="34" charset="-122"/>
-                <a:cs typeface="Calibri" pitchFamily="34" charset="-120"/>
-              </a:rPr>
-              <a:t>A vetted corpus is the guardrail, and a person edits every finding before a client sees it.</a:t>
-            </a:r>
             <a:endParaRPr lang="en-US" sz="1550" dirty="0"/>
           </a:p>
         </p:txBody>
@@ -11035,7 +11035,7 @@
                 <a:ea typeface="Calibri" pitchFamily="34" charset="-122"/>
                 <a:cs typeface="Calibri" pitchFamily="34" charset="-120"/>
               </a:rPr>
-              <a:t>GPT-4 retrieves against Morgan Stanley's own research library rather than the open web, so the model never reaches past vetted material.</a:t>
+              <a:t>GPT-4 answers exclusively from internal Morgan Stanley content, never the open web, and they say plainly they are not using ChatGPT.</a:t>
             </a:r>
             <a:endParaRPr lang="en-US" sz="1100" dirty="0"/>
           </a:p>
@@ -11059,7 +11059,7 @@
                 <a:ea typeface="Calibri" pitchFamily="34" charset="-122"/>
                 <a:cs typeface="Calibri" pitchFamily="34" charset="-120"/>
               </a:rPr>
-              <a:t>AskResearchGPT extends the earlier AskResearch chatbot across more than 70,000 proprietary research reports a year.</a:t>
+              <a:t>Two systems: the Assistant for Wealth Management, and AskResearchGPT across 70,000+ research reports a year for Institutional Securities.</a:t>
             </a:r>
             <a:endParaRPr lang="en-US" sz="1100" dirty="0"/>
           </a:p>
@@ -11278,7 +11278,7 @@
                 <a:ea typeface="Calibri" pitchFamily="34" charset="-122"/>
                 <a:cs typeface="Calibri" pitchFamily="34" charset="-120"/>
               </a:rPr>
-              <a:t>Findings are handed to a person to edit rather than sent onward automatically, so a human is always in the path to the client.</a:t>
+              <a:t>Their Co-President states it directly: the Financial Advisor and their teams remain the centre of the wealth management universe.</a:t>
             </a:r>
             <a:endParaRPr lang="en-US" sz="1100" dirty="0"/>
           </a:p>
@@ -11473,7 +11473,7 @@
                 <a:ea typeface="Calibri" pitchFamily="34" charset="-122"/>
                 <a:cs typeface="Calibri" pitchFamily="34" charset="-120"/>
               </a:rPr>
-              <a:t>Wealth-management advisors from the September 2023 rollout, with Institutional Securities added in 2024.</a:t>
+              <a:t>Announced March 2023; the Assistant rolled out to wealth-management advisors, AskResearchGPT to Institutional Securities in October 2024.</a:t>
             </a:r>
             <a:endParaRPr lang="en-US" sz="1100" dirty="0"/>
           </a:p>
@@ -11497,7 +11497,7 @@
                 <a:ea typeface="Calibri" pitchFamily="34" charset="-122"/>
                 <a:cs typeface="Calibri" pitchFamily="34" charset="-120"/>
               </a:rPr>
-              <a:t>Staff ask roughly three times more questions than they did of the previous tool, which suggests the friction was the barrier.</a:t>
+              <a:t>Over 98% of advisor teams use the Assistant daily, and document access has risen from 20% to 80%.</a:t>
             </a:r>
             <a:endParaRPr lang="en-US" sz="1100" dirty="0"/>
           </a:p>
@@ -11521,7 +11521,7 @@
                 <a:ea typeface="Calibri" pitchFamily="34" charset="-122"/>
                 <a:cs typeface="Calibri" pitchFamily="34" charset="-120"/>
               </a:rPr>
-              <a:t>Salespeople answer client queries in about a tenth of the time, and a reported 98% of advisor teams are active.</a:t>
+              <a:t>Three times the questions of the old tool, and a tenth of the time per client query, are CNBC interview figures rather than disclosure.</a:t>
             </a:r>
             <a:endParaRPr lang="en-US" sz="1100" dirty="0"/>
           </a:p>
@@ -11716,7 +11716,7 @@
                 <a:ea typeface="Calibri" pitchFamily="34" charset="-122"/>
                 <a:cs typeface="Calibri" pitchFamily="34" charset="-120"/>
               </a:rPr>
-              <a:t>Debrief handles meeting summarisation through Whisper and GPT-4 as a separate product alongside the assistant.</a:t>
+              <a:t>Every use case is evaluated before deployment: summarization evals graded by advisors, then translation evals for multilingual clients.</a:t>
             </a:r>
             <a:endParaRPr lang="en-US" sz="1100" dirty="0"/>
           </a:p>
@@ -11740,7 +11740,7 @@
                 <a:ea typeface="Calibri" pitchFamily="34" charset="-122"/>
                 <a:cs typeface="Calibri" pitchFamily="34" charset="-120"/>
               </a:rPr>
-              <a:t>There is no public account of reindexing, eval cadence or drift handling, making this the least documented of the first-party set.</a:t>
+              <a:t>A daily regression suite of sample questions runs as standing QA, and retrieval methods are tuned with OpenAI against the results.</a:t>
             </a:r>
             <a:endParaRPr lang="en-US" sz="1100" dirty="0"/>
           </a:p>
@@ -11860,7 +11860,7 @@
                 <a:ea typeface="Cambria" pitchFamily="34" charset="-122"/>
                 <a:cs typeface="Cambria" pitchFamily="34" charset="-120"/>
               </a:rPr>
-              <a:t>3x</a:t>
+              <a:t>80%</a:t>
             </a:r>
             <a:endParaRPr lang="en-US" sz="1900" dirty="0"/>
           </a:p>
@@ -11902,7 +11902,7 @@
                 <a:ea typeface="Calibri" pitchFamily="34" charset="-122"/>
                 <a:cs typeface="Calibri" pitchFamily="34" charset="-120"/>
               </a:rPr>
-              <a:t>more questions asked than of the old tool</a:t>
+              <a:t>of documents reachable, up from 20%</a:t>
             </a:r>
             <a:endParaRPr lang="en-US" sz="950" dirty="0"/>
           </a:p>
@@ -11941,7 +11941,7 @@
                 <a:ea typeface="Cambria" pitchFamily="34" charset="-122"/>
                 <a:cs typeface="Cambria" pitchFamily="34" charset="-120"/>
               </a:rPr>
-              <a:t>~10x</a:t>
+              <a:t>daily</a:t>
             </a:r>
             <a:endParaRPr lang="en-US" sz="1900" dirty="0"/>
           </a:p>
@@ -11983,7 +11983,7 @@
                 <a:ea typeface="Calibri" pitchFamily="34" charset="-122"/>
                 <a:cs typeface="Calibri" pitchFamily="34" charset="-120"/>
               </a:rPr>
-              <a:t>faster turnaround on client queries</a:t>
+              <a:t>regression suite of sample questions</a:t>
             </a:r>
             <a:endParaRPr lang="en-US" sz="950" dirty="0"/>
           </a:p>
@@ -12064,7 +12064,7 @@
                 <a:ea typeface="Calibri" pitchFamily="34" charset="-122"/>
                 <a:cs typeface="Calibri" pitchFamily="34" charset="-120"/>
               </a:rPr>
-              <a:t>of advisor teams active (press figure)</a:t>
+              <a:t>of advisor teams use the Assistant daily</a:t>
             </a:r>
             <a:endParaRPr lang="en-US" sz="950" dirty="0"/>
           </a:p>
@@ -12262,7 +12262,7 @@
                 <a:ea typeface="Calibri" pitchFamily="34" charset="-122"/>
                 <a:cs typeface="Calibri" pitchFamily="34" charset="-120"/>
               </a:rPr>
-              <a:t>FIRST-PARTY PR / SEARCH-SURFACED</a:t>
+              <a:t>FIRST-PARTY PR</a:t>
             </a:r>
             <a:endParaRPr lang="en-US" sz="850" dirty="0"/>
           </a:p>
@@ -13591,7 +13591,7 @@
                 <a:ea typeface="Calibri" pitchFamily="34" charset="-122"/>
                 <a:cs typeface="Calibri" pitchFamily="34" charset="-120"/>
               </a:rPr>
-              <a:t>Source caveat: this diagram is reconstructed from press releases, not an engineering write-up. The corpus size, the retrieval approach and the one-click workflow are all first-party claims; the internal mechanics between them are not published and are not guessed at here.</a:t>
+              <a:t>Source note: both press releases and the OpenAI case study were read in full on 3 September 2026. The corpus, the retrieval boundary, the patented workflow and the eval framework behind it are all first-party; the internal mechanics between these boxes are still unpublished and are not guessed at here.</a:t>
             </a:r>
             <a:endParaRPr lang="en-US" sz="1050" dirty="0"/>
           </a:p>
@@ -14710,7 +14710,7 @@
                 <a:ea typeface="Calibri" pitchFamily="34" charset="-122"/>
                 <a:cs typeface="Calibri" pitchFamily="34" charset="-120"/>
               </a:rPr>
-              <a:t>&gt;98% of advisor teams active (reported)</a:t>
+              <a:t>&gt;98% of advisor teams active (Assistant)</a:t>
             </a:r>
             <a:endParaRPr lang="en-US" sz="1200" dirty="0"/>
           </a:p>
@@ -17668,7 +17668,7 @@
                           <a:ea typeface="Calibri" pitchFamily="34" charset="-122"/>
                           <a:cs typeface="Calibri" pitchFamily="34" charset="-120"/>
                         </a:rPr>
-                        <a:t>The firm's research pipeline</a:t>
+                        <a:t>Research pipeline, daily regression suite</a:t>
                       </a:r>
                       <a:endParaRPr lang="en-US" sz="1000" dirty="0">
                         <a:latin typeface="Calibri" charset="0"/>
@@ -18656,7 +18656,7 @@
                 <a:ea typeface="Calibri" pitchFamily="34" charset="-122"/>
                 <a:cs typeface="Calibri" pitchFamily="34" charset="-120"/>
               </a:rPr>
-              <a:t>Differential sync, Spark ETL, incremental re-embedding. Nobody promises currency as a rule, because a rule cannot be enforced and a pipeline can.</a:t>
+              <a:t>Differential sync, Spark ETL, incremental re-embedding, a daily regression suite. Nobody promises currency as a rule, because a rule cannot be enforced and a pipeline can.</a:t>
             </a:r>
             <a:endParaRPr lang="en-US" sz="1150" dirty="0"/>
           </a:p>
@@ -19582,7 +19582,7 @@
                 <a:ea typeface="Calibri" pitchFamily="34" charset="-122"/>
                 <a:cs typeface="Calibri" pitchFamily="34" charset="-120"/>
               </a:rPr>
-              <a:t>A newsroom post we could not open, so detail comes from search results quoting it.</a:t>
+              <a:t>A newsroom post or vendor case study, read in full, but not an engineering account.</a:t>
             </a:r>
             <a:endParaRPr lang="en-US" sz="1150" dirty="0"/>
           </a:p>
@@ -19725,7 +19725,7 @@
                 <a:ea typeface="Calibri" pitchFamily="34" charset="-122"/>
                 <a:cs typeface="Calibri" pitchFamily="34" charset="-120"/>
               </a:rPr>
-              <a:t>Six of the eight published a real engineering account. Morgan Stanley blocked automated fetches, so its figures come from search results quoting its own releases. JPMorgan published no architecture at all, and so appears only as a scale datapoint, with no diagram and no four-question read.</a:t>
+              <a:t>Six of the eight published a real engineering account. Morgan Stanley published press releases and an OpenAI case study instead, read in full but thinner on mechanism. JPMorgan published no architecture at all, and so appears only as a scale datapoint, with no diagram and no four-question read.</a:t>
             </a:r>
             <a:endParaRPr lang="en-US" sz="1200" dirty="0"/>
           </a:p>
@@ -22225,7 +22225,7 @@
                 <a:ea typeface="Calibri" pitchFamily="34" charset="-122"/>
                 <a:cs typeface="Calibri" pitchFamily="34" charset="-120"/>
               </a:rPr>
-              <a:t>Morgan Stanley: “advisors may not forward assistant output to clients”</a:t>
+              <a:t>Morgan Stanley: “advisors may not forward assistant output to clients” is refuted</a:t>
             </a:r>
             <a:endParaRPr lang="en-US" sz="1300" dirty="0"/>
           </a:p>
@@ -22267,7 +22267,7 @@
                 <a:ea typeface="Calibri" pitchFamily="34" charset="-122"/>
                 <a:cs typeface="Calibri" pitchFamily="34" charset="-120"/>
               </a:rPr>
-              <a:t>This appears in third-party writeups and in no first-party source, and it sits awkwardly against a confirmed first-party feature: a patented one-click export of findings into a client email draft. Do not repeat it as fact.</a:t>
+              <a:t>This appears only in third-party writeups. The October 2024 release states the opposite mechanism: a patented one-click export moves findings into an email draft “ready to be modified and customized before sharing with their clients.” A person edits before sending. That is the constraint, not a bar on sending.</a:t>
             </a:r>
             <a:endParaRPr lang="en-US" sz="1100" dirty="0"/>
           </a:p>
@@ -22326,7 +22326,7 @@
                 <a:ea typeface="Calibri" pitchFamily="34" charset="-122"/>
                 <a:cs typeface="Calibri" pitchFamily="34" charset="-120"/>
               </a:rPr>
-              <a:t>Morgan Stanley's figures are search-surfaced, not fetched</a:t>
+              <a:t>Morgan Stanley: two figures are trade press, not disclosure</a:t>
             </a:r>
             <a:endParaRPr lang="en-US" sz="1300" dirty="0"/>
           </a:p>
@@ -22368,7 +22368,7 @@
                 <a:ea typeface="Calibri" pitchFamily="34" charset="-122"/>
                 <a:cs typeface="Calibri" pitchFamily="34" charset="-120"/>
               </a:rPr>
-              <a:t>morganstanley.com reset the connection and openai.com returned 403, so the corpus size, the 3x question volume and the &gt;98% adoption figure all come from excerpts of first-party pages rather than the pages themselves.</a:t>
+              <a:t>All three first-party sources have now been read in full, so the corpus size, the &gt;98% adoption and the eval framework are first-party. The 3x question volume and the tenfold turnaround appear in neither press release; both are CNBC interview claims.</a:t>
             </a:r>
             <a:endParaRPr lang="en-US" sz="1100" dirty="0"/>
           </a:p>
@@ -22806,6 +22806,10 @@
           </a:solidFill>
           <a:ln/>
         </p:spPr>
+        <p:txBody>
+          <a:bodyPr/>
+          <a:p/>
+        </p:txBody>
       </p:sp>
       <p:sp>
         <p:nvSpPr>
@@ -23333,6 +23337,10 @@
           </a:solidFill>
           <a:ln/>
         </p:spPr>
+        <p:txBody>
+          <a:bodyPr/>
+          <a:p/>
+        </p:txBody>
       </p:sp>
       <p:sp>
         <p:nvSpPr>
@@ -23367,7 +23375,7 @@
                 <a:ea typeface="Calibri" pitchFamily="34" charset="-122"/>
                 <a:cs typeface="Calibri" pitchFamily="34" charset="-120"/>
               </a:rPr>
-              <a:t>First-party PR, search-surfaced (bodies not fetchable)</a:t>
+              <a:t>First-party PR and vendor case study, read in full</a:t>
             </a:r>
             <a:endParaRPr lang="en-US" sz="1300" dirty="0"/>
           </a:p>
@@ -23562,7 +23570,7 @@
                 <a:ea typeface="Calibri" pitchFamily="34" charset="-122"/>
                 <a:cs typeface="Calibri" pitchFamily="34" charset="-120"/>
               </a:rPr>
-              <a:t>OpenAI, Morgan Stanley case study (HTTP 403)</a:t>
+              <a:t>OpenAI, Morgan Stanley uses AI evals (case study)</a:t>
             </a:r>
             <a:endParaRPr lang="en-US" sz="1100" dirty="0"/>
           </a:p>
@@ -23626,6 +23634,10 @@
           </a:solidFill>
           <a:ln/>
         </p:spPr>
+        <p:txBody>
+          <a:bodyPr/>
+          <a:p/>
+        </p:txBody>
       </p:sp>
       <p:sp>
         <p:nvSpPr>
@@ -23819,7 +23831,7 @@
                 <a:ea typeface="Calibri" pitchFamily="34" charset="-122"/>
                 <a:cs typeface="Calibri" pitchFamily="34" charset="-120"/>
               </a:rPr>
-              <a:t>Compiled from PRIOR-ART.md for companywiki, 27 August 2026</a:t>
+              <a:t>Compiled from PRIOR-ART.md for companywiki, 27 August 2026. Morgan Stanley re-sourced from primary text, 3 September 2026.</a:t>
             </a:r>
             <a:endParaRPr lang="en-US" sz="950" dirty="0"/>
           </a:p>

</xml_diff>